<commit_message>
Add high-level technology and Azure hosting overview
</commit_message>
<xml_diff>
--- a/GoodsPass-Public-Teaser.pptx
+++ b/GoodsPass-Public-Teaser.pptx
@@ -14,9 +14,10 @@
     <p:sldId id="262" r:id="rId8"/>
     <p:sldId id="263" r:id="rId9"/>
     <p:sldId id="264" r:id="rId10"/>
+    <p:sldId id="265" r:id="rId11"/>
   </p:sldIdLst>
   <p:notesMasterIdLst>
-    <p:notesMasterId r:id="rId11"/>
+    <p:notesMasterId r:id="rId12"/>
   </p:notesMasterIdLst>
   <p:sldSz cx="12192000" cy="6858000"/>
   <p:notesSz cx="6858000" cy="12192000"/>
@@ -534,6 +535,94 @@
             <a:fld id="{F7021451-1387-4CA6-816F-3879F97B5CBC}" type="slidenum">
               <a:rPr lang="en-US"/>
               <a:t>1</a:t>
+            </a:fld>
+            <a:endParaRPr lang="en-US"/>
+          </a:p>
+        </p:txBody>
+      </p:sp>
+    </p:spTree>
+    <p:extLst>
+      <p:ext uri="{BB962C8B-B14F-4D97-AF65-F5344CB8AC3E}">
+        <p14:creationId xmlns:p14="http://schemas.microsoft.com/office/powerpoint/2010/main" val="1024086991"/>
+      </p:ext>
+    </p:extLst>
+  </p:cSld>
+  <p:clrMapOvr>
+    <a:masterClrMapping/>
+  </p:clrMapOvr>
+</p:notes>
+</file>
+
+<file path=ppt/notesSlides/notesSlide10.xml><?xml version="1.0" encoding="utf-8"?>
+<p:notes xmlns:a="http://schemas.openxmlformats.org/drawingml/2006/main" xmlns:r="http://schemas.openxmlformats.org/officeDocument/2006/relationships" xmlns:p="http://schemas.openxmlformats.org/presentationml/2006/main">
+  <p:cSld>
+    <p:spTree>
+      <p:nvGrpSpPr>
+        <p:cNvPr id="1" name=""/>
+        <p:cNvGrpSpPr/>
+        <p:nvPr/>
+      </p:nvGrpSpPr>
+      <p:grpSpPr>
+        <a:xfrm>
+          <a:off x="0" y="0"/>
+          <a:ext cx="0" cy="0"/>
+          <a:chOff x="0" y="0"/>
+          <a:chExt cx="0" cy="0"/>
+        </a:xfrm>
+      </p:grpSpPr>
+      <p:sp>
+        <p:nvSpPr>
+          <p:cNvPr id="2" name="Slide Image Placeholder 1"/>
+          <p:cNvSpPr>
+            <a:spLocks noGrp="1" noRot="1" noChangeAspect="1"/>
+          </p:cNvSpPr>
+          <p:nvPr>
+            <p:ph type="sldImg"/>
+          </p:nvPr>
+        </p:nvSpPr>
+        <p:spPr/>
+      </p:sp>
+      <p:sp>
+        <p:nvSpPr>
+          <p:cNvPr id="3" name="Notes Placeholder 2"/>
+          <p:cNvSpPr>
+            <a:spLocks noGrp="1"/>
+          </p:cNvSpPr>
+          <p:nvPr>
+            <p:ph type="body" idx="1"/>
+          </p:nvPr>
+        </p:nvSpPr>
+        <p:spPr/>
+        <p:txBody>
+          <a:bodyPr/>
+          <a:lstStyle/>
+          <a:p>
+            <a:r>
+              <a:rPr lang="en-US" dirty="0"/>
+              <a:t/>
+            </a:r>
+            <a:endParaRPr lang="en-US" dirty="0"/>
+          </a:p>
+        </p:txBody>
+      </p:sp>
+      <p:sp>
+        <p:nvSpPr>
+          <p:cNvPr id="4" name="Slide Number Placeholder 3"/>
+          <p:cNvSpPr>
+            <a:spLocks noGrp="1"/>
+          </p:cNvSpPr>
+          <p:nvPr>
+            <p:ph type="sldNum" sz="quarter" idx="10"/>
+          </p:nvPr>
+        </p:nvSpPr>
+        <p:spPr/>
+        <p:txBody>
+          <a:bodyPr/>
+          <a:lstStyle/>
+          <a:p>
+            <a:fld id="{F7021451-1387-4CA6-816F-3879F97B5CBC}" type="slidenum">
+              <a:rPr lang="en-US"/>
+              <a:t>10</a:t>
             </a:fld>
             <a:endParaRPr lang="en-US"/>
           </a:p>
@@ -1834,7 +1923,326 @@
                 <a:ea typeface="Aptos" pitchFamily="34" charset="-122"/>
                 <a:cs typeface="Aptos" pitchFamily="34" charset="-120"/>
               </a:rPr>
-              <a:t>01 / 09</a:t>
+              <a:t>01 / 10</a:t>
+            </a:r>
+            <a:endParaRPr lang="en-US" sz="700" dirty="0"/>
+          </a:p>
+        </p:txBody>
+      </p:sp>
+    </p:spTree>
+  </p:cSld>
+  <p:clrMapOvr>
+    <a:masterClrMapping/>
+  </p:clrMapOvr>
+</p:sld>
+</file>
+
+<file path=ppt/slides/slide10.xml><?xml version="1.0" encoding="utf-8"?>
+<p:sld xmlns:a="http://schemas.openxmlformats.org/drawingml/2006/main" xmlns:r="http://schemas.openxmlformats.org/officeDocument/2006/relationships" xmlns:p="http://schemas.openxmlformats.org/presentationml/2006/main">
+  <p:cSld name="Slide 10">
+    <p:bg>
+      <p:bgPr>
+        <a:solidFill>
+          <a:srgbClr val="F6F4ED"/>
+        </a:solidFill>
+      </p:bgPr>
+    </p:bg>
+    <p:spTree>
+      <p:nvGrpSpPr>
+        <p:cNvPr id="1" name=""/>
+        <p:cNvGrpSpPr/>
+        <p:nvPr/>
+      </p:nvGrpSpPr>
+      <p:grpSpPr>
+        <a:xfrm>
+          <a:off x="0" y="0"/>
+          <a:ext cx="0" cy="0"/>
+          <a:chOff x="0" y="0"/>
+          <a:chExt cx="0" cy="0"/>
+        </a:xfrm>
+      </p:grpSpPr>
+      <p:sp>
+        <p:nvSpPr>
+          <p:cNvPr id="2" name="Shape 0"/>
+          <p:cNvSpPr/>
+          <p:nvPr/>
+        </p:nvSpPr>
+        <p:spPr>
+          <a:xfrm>
+            <a:off x="9326880" y="-1097280"/>
+            <a:ext cx="4023360" cy="4023360"/>
+          </a:xfrm>
+          <a:prstGeom prst="ellipse">
+            <a:avLst/>
+          </a:prstGeom>
+          <a:solidFill>
+            <a:srgbClr val="EDF3F0">
+              <a:alpha val="88000"/>
+            </a:srgbClr>
+          </a:solidFill>
+          <a:ln w="12700">
+            <a:solidFill>
+              <a:srgbClr val="0D5F61">
+                <a:alpha val="35000"/>
+              </a:srgbClr>
+            </a:solidFill>
+            <a:prstDash val="solid"/>
+          </a:ln>
+        </p:spPr>
+      </p:sp>
+      <p:pic>
+        <p:nvPicPr>
+          <p:cNvPr id="3" name="Image 0" descr="/srv/projects/eu-tcp-worktrees/azure-release-integrator-20260904/docs/investors/assets/goodspass-mark.svg">    </p:cNvPr>
+          <p:cNvPicPr>
+            <a:picLocks noChangeAspect="1"/>
+          </p:cNvPicPr>
+          <p:nvPr/>
+        </p:nvPicPr>
+        <p:blipFill>
+          <a:blip r:embed="rId1">
+            <a:extLst>
+              <a:ext uri="{96DAC541-7B7A-43D3-8B79-37D633B846F1}">
+                <asvg:svgBlip xmlns:asvg="http://schemas.microsoft.com/office/drawing/2016/SVG/main" r:embed="rId2"/>
+              </a:ext>
+            </a:extLst>
+          </a:blip>
+          <a:stretch>
+            <a:fillRect/>
+          </a:stretch>
+        </p:blipFill>
+        <p:spPr>
+          <a:xfrm>
+            <a:off x="502920" y="310896"/>
+            <a:ext cx="347472" cy="347472"/>
+          </a:xfrm>
+          <a:prstGeom prst="rect">
+            <a:avLst/>
+          </a:prstGeom>
+        </p:spPr>
+      </p:pic>
+      <p:sp>
+        <p:nvSpPr>
+          <p:cNvPr id="4" name="Text 1"/>
+          <p:cNvSpPr/>
+          <p:nvPr/>
+        </p:nvSpPr>
+        <p:spPr>
+          <a:xfrm>
+            <a:off x="932688" y="356616"/>
+            <a:ext cx="1463040" cy="201168"/>
+          </a:xfrm>
+          <a:prstGeom prst="rect">
+            <a:avLst/>
+          </a:prstGeom>
+          <a:noFill/>
+          <a:ln/>
+        </p:spPr>
+        <p:txBody>
+          <a:bodyPr wrap="square" lIns="0" tIns="0" rIns="0" bIns="0" rtlCol="0" anchor="ctr"/>
+          <a:lstStyle/>
+          <a:p>
+            <a:pPr indent="0" marL="0">
+              <a:buNone/>
+            </a:pPr>
+            <a:r>
+              <a:rPr lang="en-US" sz="1100" b="1" dirty="0">
+                <a:solidFill>
+                  <a:srgbClr val="071F2B"/>
+                </a:solidFill>
+                <a:latin typeface="Aptos" pitchFamily="34" charset="0"/>
+                <a:ea typeface="Aptos" pitchFamily="34" charset="-122"/>
+                <a:cs typeface="Aptos" pitchFamily="34" charset="-120"/>
+              </a:rPr>
+              <a:t>GoodsPass</a:t>
+            </a:r>
+            <a:endParaRPr lang="en-US" sz="1100" dirty="0"/>
+          </a:p>
+        </p:txBody>
+      </p:sp>
+      <p:sp>
+        <p:nvSpPr>
+          <p:cNvPr id="5" name="Text 2"/>
+          <p:cNvSpPr/>
+          <p:nvPr/>
+        </p:nvSpPr>
+        <p:spPr>
+          <a:xfrm>
+            <a:off x="502920" y="1005840"/>
+            <a:ext cx="10607040" cy="1051560"/>
+          </a:xfrm>
+          <a:prstGeom prst="rect">
+            <a:avLst/>
+          </a:prstGeom>
+          <a:noFill/>
+          <a:ln/>
+        </p:spPr>
+        <p:txBody>
+          <a:bodyPr wrap="square" lIns="0" tIns="0" rIns="0" bIns="0" rtlCol="0" anchor="ctr">
+            <a:normAutofit/>
+          </a:bodyPr>
+          <a:lstStyle/>
+          <a:p>
+            <a:pPr indent="0" marL="0">
+              <a:buNone/>
+            </a:pPr>
+            <a:r>
+              <a:rPr lang="en-US" sz="3000" dirty="0">
+                <a:solidFill>
+                  <a:srgbClr val="102B32"/>
+                </a:solidFill>
+                <a:latin typeface="Georgia" pitchFamily="34" charset="0"/>
+                <a:ea typeface="Georgia" pitchFamily="34" charset="-122"/>
+                <a:cs typeface="Georgia" pitchFamily="34" charset="-120"/>
+              </a:rPr>
+              <a:t>Let's discuss the evidence</a:t>
+            </a:r>
+            <a:endParaRPr lang="en-US" sz="3000" dirty="0"/>
+          </a:p>
+        </p:txBody>
+      </p:sp>
+      <p:sp>
+        <p:nvSpPr>
+          <p:cNvPr id="6" name="Text 3"/>
+          <p:cNvSpPr/>
+          <p:nvPr/>
+        </p:nvSpPr>
+        <p:spPr>
+          <a:xfrm>
+            <a:off x="548640" y="2331720"/>
+            <a:ext cx="10789920" cy="3429000"/>
+          </a:xfrm>
+          <a:prstGeom prst="rect">
+            <a:avLst/>
+          </a:prstGeom>
+          <a:noFill/>
+          <a:ln/>
+        </p:spPr>
+        <p:txBody>
+          <a:bodyPr wrap="square" lIns="381" tIns="381" rIns="381" bIns="381" rtlCol="0" anchor="t">
+            <a:normAutofit/>
+          </a:bodyPr>
+          <a:lstStyle/>
+          <a:p>
+            <a:pPr indent="0" marL="0">
+              <a:buNone/>
+            </a:pPr>
+            <a:r>
+              <a:rPr lang="en-US" sz="1500" dirty="0">
+                <a:solidFill>
+                  <a:srgbClr val="607277"/>
+                </a:solidFill>
+                <a:latin typeface="Aptos" pitchFamily="34" charset="0"/>
+                <a:ea typeface="Aptos" pitchFamily="34" charset="-122"/>
+                <a:cs typeface="Aptos" pitchFamily="34" charset="-120"/>
+              </a:rPr>
+              <a:t>We can share a product demonstration using synthetic documents, a staged commercial-validation plan and a detailed investment case through controlled access.</a:t>
+            </a:r>
+            <a:endParaRPr lang="en-US" sz="1500" dirty="0"/>
+          </a:p>
+          <a:p>
+            <a:pPr indent="0" marL="0">
+              <a:buNone/>
+            </a:pPr>
+            <a:r>
+              <a:rPr lang="en-US" sz="1500" dirty="0">
+                <a:solidFill>
+                  <a:srgbClr val="607277"/>
+                </a:solidFill>
+                <a:latin typeface="Aptos" pitchFamily="34" charset="0"/>
+                <a:ea typeface="Aptos" pitchFamily="34" charset="-122"/>
+                <a:cs typeface="Aptos" pitchFamily="34" charset="-120"/>
+              </a:rPr>
+              <a:t>Cristian Apostol · Managing Partner</a:t>
+            </a:r>
+            <a:endParaRPr lang="en-US" sz="1500" dirty="0"/>
+          </a:p>
+          <a:p>
+            <a:pPr indent="0" marL="0">
+              <a:buNone/>
+            </a:pPr>
+            <a:r>
+              <a:rPr lang="en-US" sz="1500" dirty="0">
+                <a:solidFill>
+                  <a:srgbClr val="607277"/>
+                </a:solidFill>
+                <a:latin typeface="Aptos" pitchFamily="34" charset="0"/>
+                <a:ea typeface="Aptos" pitchFamily="34" charset="-122"/>
+                <a:cs typeface="Aptos" pitchFamily="34" charset="-120"/>
+              </a:rPr>
+              <a:t>CLARIFIED SRL · Bucharest, Romania</a:t>
+            </a:r>
+            <a:endParaRPr lang="en-US" sz="1500" dirty="0"/>
+          </a:p>
+          <a:p>
+            <a:pPr indent="0" marL="0">
+              <a:buNone/>
+            </a:pPr>
+            <a:r>
+              <a:rPr lang="en-US" sz="1500" dirty="0">
+                <a:solidFill>
+                  <a:srgbClr val="607277"/>
+                </a:solidFill>
+                <a:latin typeface="Aptos" pitchFamily="34" charset="0"/>
+                <a:ea typeface="Aptos" pitchFamily="34" charset="-122"/>
+                <a:cs typeface="Aptos" pitchFamily="34" charset="-120"/>
+              </a:rPr>
+              <a:t>office@clarified.ro · https://goodspass.ro</a:t>
+            </a:r>
+            <a:endParaRPr lang="en-US" sz="1500" dirty="0"/>
+          </a:p>
+          <a:p>
+            <a:pPr indent="0" marL="0">
+              <a:buNone/>
+            </a:pPr>
+            <a:r>
+              <a:rPr lang="en-US" sz="1500" dirty="0">
+                <a:solidFill>
+                  <a:srgbClr val="607277"/>
+                </a:solidFill>
+                <a:latin typeface="Aptos" pitchFamily="34" charset="0"/>
+                <a:ea typeface="Aptos" pitchFamily="34" charset="-122"/>
+                <a:cs typeface="Aptos" pitchFamily="34" charset="-120"/>
+              </a:rPr>
+              <a:t>This introduction is non-confidential. It is not a funding commitment, investment guarantee or claim of regulatory approval.</a:t>
+            </a:r>
+            <a:endParaRPr lang="en-US" sz="1500" dirty="0"/>
+          </a:p>
+        </p:txBody>
+      </p:sp>
+      <p:sp>
+        <p:nvSpPr>
+          <p:cNvPr id="7" name="Text 4"/>
+          <p:cNvSpPr/>
+          <p:nvPr/>
+        </p:nvSpPr>
+        <p:spPr>
+          <a:xfrm>
+            <a:off x="10789920" y="6473952"/>
+            <a:ext cx="822960" cy="146304"/>
+          </a:xfrm>
+          <a:prstGeom prst="rect">
+            <a:avLst/>
+          </a:prstGeom>
+          <a:noFill/>
+          <a:ln/>
+        </p:spPr>
+        <p:txBody>
+          <a:bodyPr wrap="square" lIns="0" tIns="0" rIns="0" bIns="0" rtlCol="0" anchor="ctr"/>
+          <a:lstStyle/>
+          <a:p>
+            <a:pPr algn="r" indent="0" marL="0">
+              <a:buNone/>
+            </a:pPr>
+            <a:r>
+              <a:rPr lang="en-US" sz="700" dirty="0">
+                <a:solidFill>
+                  <a:srgbClr val="607277"/>
+                </a:solidFill>
+                <a:latin typeface="Aptos" pitchFamily="34" charset="0"/>
+                <a:ea typeface="Aptos" pitchFamily="34" charset="-122"/>
+                <a:cs typeface="Aptos" pitchFamily="34" charset="-120"/>
+              </a:rPr>
+              <a:t>10 / 10</a:t>
             </a:r>
             <a:endParaRPr lang="en-US" sz="700" dirty="0"/>
           </a:p>
@@ -2102,7 +2510,7 @@
                 <a:ea typeface="Aptos" pitchFamily="34" charset="-122"/>
                 <a:cs typeface="Aptos" pitchFamily="34" charset="-120"/>
               </a:rPr>
-              <a:t>02 / 09</a:t>
+              <a:t>02 / 10</a:t>
             </a:r>
             <a:endParaRPr lang="en-US" sz="700" dirty="0"/>
           </a:p>
@@ -2370,7 +2778,7 @@
                 <a:ea typeface="Aptos" pitchFamily="34" charset="-122"/>
                 <a:cs typeface="Aptos" pitchFamily="34" charset="-120"/>
               </a:rPr>
-              <a:t>03 / 09</a:t>
+              <a:t>03 / 10</a:t>
             </a:r>
             <a:endParaRPr lang="en-US" sz="700" dirty="0"/>
           </a:p>
@@ -2638,7 +3046,7 @@
                 <a:ea typeface="Aptos" pitchFamily="34" charset="-122"/>
                 <a:cs typeface="Aptos" pitchFamily="34" charset="-120"/>
               </a:rPr>
-              <a:t>04 / 09</a:t>
+              <a:t>04 / 10</a:t>
             </a:r>
             <a:endParaRPr lang="en-US" sz="700" dirty="0"/>
           </a:p>
@@ -2923,7 +3331,7 @@
                 <a:ea typeface="Aptos" pitchFamily="34" charset="-122"/>
                 <a:cs typeface="Aptos" pitchFamily="34" charset="-120"/>
               </a:rPr>
-              <a:t>05 / 09</a:t>
+              <a:t>05 / 10</a:t>
             </a:r>
             <a:endParaRPr lang="en-US" sz="700" dirty="0"/>
           </a:p>
@@ -3191,7 +3599,7 @@
                 <a:ea typeface="Aptos" pitchFamily="34" charset="-122"/>
                 <a:cs typeface="Aptos" pitchFamily="34" charset="-120"/>
               </a:rPr>
-              <a:t>06 / 09</a:t>
+              <a:t>06 / 10</a:t>
             </a:r>
             <a:endParaRPr lang="en-US" sz="700" dirty="0"/>
           </a:p>
@@ -3362,7 +3770,7 @@
                 <a:ea typeface="Georgia" pitchFamily="34" charset="-122"/>
                 <a:cs typeface="Georgia" pitchFamily="34" charset="-120"/>
               </a:rPr>
-              <a:t>The next product chapter</a:t>
+              <a:t>Technology and hosting</a:t>
             </a:r>
             <a:endParaRPr lang="en-US" sz="3000" dirty="0"/>
           </a:p>
@@ -3403,7 +3811,7 @@
                 <a:ea typeface="Aptos" pitchFamily="34" charset="-122"/>
                 <a:cs typeface="Aptos" pitchFamily="34" charset="-120"/>
               </a:rPr>
-              <a:t>A controlled AI assistant could help users prepare and complete authorised workflow steps, starting with suggestions and reviewable actions.</a:t>
+              <a:t>Web experience: HTML, CSS and JavaScript in the browser.</a:t>
             </a:r>
             <a:endParaRPr lang="en-US" sz="1500" dirty="0"/>
           </a:p>
@@ -3420,38 +3828,16 @@
                 <a:ea typeface="Aptos" pitchFamily="34" charset="-122"/>
                 <a:cs typeface="Aptos" pitchFamily="34" charset="-120"/>
               </a:rPr>
-              <a:t>Client permissions, tenant isolation and explicit approval for legally or financially consequential actions come first. Autonomous official filing is not a current product claim.</a:t>
+              <a:t>Application and data: a Node.js modular application with PostgreSQL persistence.</a:t>
             </a:r>
             <a:endParaRPr lang="en-US" sz="1500" dirty="0"/>
           </a:p>
-        </p:txBody>
-      </p:sp>
-      <p:sp>
-        <p:nvSpPr>
-          <p:cNvPr id="7" name="Text 4"/>
-          <p:cNvSpPr/>
-          <p:nvPr/>
-        </p:nvSpPr>
-        <p:spPr>
-          <a:xfrm>
-            <a:off x="10789920" y="6473952"/>
-            <a:ext cx="822960" cy="146304"/>
-          </a:xfrm>
-          <a:prstGeom prst="rect">
-            <a:avLst/>
-          </a:prstGeom>
-          <a:noFill/>
-          <a:ln/>
-        </p:spPr>
-        <p:txBody>
-          <a:bodyPr wrap="square" lIns="0" tIns="0" rIns="0" bIns="0" rtlCol="0" anchor="ctr"/>
-          <a:lstStyle/>
-          <a:p>
-            <a:pPr algn="r" indent="0" marL="0">
-              <a:buNone/>
-            </a:pPr>
-            <a:r>
-              <a:rPr lang="en-US" sz="700" dirty="0">
+          <a:p>
+            <a:pPr indent="0" marL="0">
+              <a:buNone/>
+            </a:pPr>
+            <a:r>
+              <a:rPr lang="en-US" sz="1500" dirty="0">
                 <a:solidFill>
                   <a:srgbClr val="607277"/>
                 </a:solidFill>
@@ -3459,7 +3845,80 @@
                 <a:ea typeface="Aptos" pitchFamily="34" charset="-122"/>
                 <a:cs typeface="Aptos" pitchFamily="34" charset="-120"/>
               </a:rPr>
-              <a:t>07 / 09</a:t>
+              <a:t>Cloud hosting: Docker/Linux containers on Microsoft Azure Container Apps, using the Consumption workload profile rather than a dedicated application VM.</a:t>
+            </a:r>
+            <a:endParaRPr lang="en-US" sz="1500" dirty="0"/>
+          </a:p>
+          <a:p>
+            <a:pPr indent="0" marL="0">
+              <a:buNone/>
+            </a:pPr>
+            <a:r>
+              <a:rPr lang="en-US" sz="1500" dirty="0">
+                <a:solidFill>
+                  <a:srgbClr val="607277"/>
+                </a:solidFill>
+                <a:latin typeface="Aptos" pitchFamily="34" charset="0"/>
+                <a:ea typeface="Aptos" pitchFamily="34" charset="-122"/>
+                <a:cs typeface="Aptos" pitchFamily="34" charset="-120"/>
+              </a:rPr>
+              <a:t>Supporting services: Keycloak identity, managed secrets, OCR and document processing, with versioned integration adapters.</a:t>
+            </a:r>
+            <a:endParaRPr lang="en-US" sz="1500" dirty="0"/>
+          </a:p>
+          <a:p>
+            <a:pPr indent="0" marL="0">
+              <a:buNone/>
+            </a:pPr>
+            <a:r>
+              <a:rPr lang="en-US" sz="1500" dirty="0">
+                <a:solidFill>
+                  <a:srgbClr val="607277"/>
+                </a:solidFill>
+                <a:latin typeface="Aptos" pitchFamily="34" charset="0"/>
+                <a:ea typeface="Aptos" pitchFamily="34" charset="-122"/>
+                <a:cs typeface="Aptos" pitchFamily="34" charset="-120"/>
+              </a:rPr>
+              <a:t>These are the technology foundations, not a claim that every business workflow or future integration is complete.</a:t>
+            </a:r>
+            <a:endParaRPr lang="en-US" sz="1500" dirty="0"/>
+          </a:p>
+        </p:txBody>
+      </p:sp>
+      <p:sp>
+        <p:nvSpPr>
+          <p:cNvPr id="7" name="Text 4"/>
+          <p:cNvSpPr/>
+          <p:nvPr/>
+        </p:nvSpPr>
+        <p:spPr>
+          <a:xfrm>
+            <a:off x="10789920" y="6473952"/>
+            <a:ext cx="822960" cy="146304"/>
+          </a:xfrm>
+          <a:prstGeom prst="rect">
+            <a:avLst/>
+          </a:prstGeom>
+          <a:noFill/>
+          <a:ln/>
+        </p:spPr>
+        <p:txBody>
+          <a:bodyPr wrap="square" lIns="0" tIns="0" rIns="0" bIns="0" rtlCol="0" anchor="ctr"/>
+          <a:lstStyle/>
+          <a:p>
+            <a:pPr algn="r" indent="0" marL="0">
+              <a:buNone/>
+            </a:pPr>
+            <a:r>
+              <a:rPr lang="en-US" sz="700" dirty="0">
+                <a:solidFill>
+                  <a:srgbClr val="607277"/>
+                </a:solidFill>
+                <a:latin typeface="Aptos" pitchFamily="34" charset="0"/>
+                <a:ea typeface="Aptos" pitchFamily="34" charset="-122"/>
+                <a:cs typeface="Aptos" pitchFamily="34" charset="-120"/>
+              </a:rPr>
+              <a:t>07 / 10</a:t>
             </a:r>
             <a:endParaRPr lang="en-US" sz="700" dirty="0"/>
           </a:p>
@@ -3630,7 +4089,7 @@
                 <a:ea typeface="Georgia" pitchFamily="34" charset="-122"/>
                 <a:cs typeface="Georgia" pitchFamily="34" charset="-120"/>
               </a:rPr>
-              <a:t>What we are raising</a:t>
+              <a:t>The next product chapter</a:t>
             </a:r>
             <a:endParaRPr lang="en-US" sz="3000" dirty="0"/>
           </a:p>
@@ -3671,7 +4130,7 @@
                 <a:ea typeface="Aptos" pitchFamily="34" charset="-122"/>
                 <a:cs typeface="Aptos" pitchFamily="34" charset="-120"/>
               </a:rPr>
-              <a:t>We seek €1 million to complete commercial development, launch in Romania, strengthen delivery capacity and establish the first repeatable European expansion and distribution pathways.</a:t>
+              <a:t>A controlled AI assistant could help users prepare and complete authorised workflow steps, starting with suggestions and reviewable actions.</a:t>
             </a:r>
             <a:endParaRPr lang="en-US" sz="1500" dirty="0"/>
           </a:p>
@@ -3688,7 +4147,7 @@
                 <a:ea typeface="Aptos" pitchFamily="34" charset="-122"/>
                 <a:cs typeface="Aptos" pitchFamily="34" charset="-120"/>
               </a:rPr>
-              <a:t>We are interested in lead and co-investors with B2B software, logistics, international trade or AI-workflow expertise. Investment structure and valuation are open for discussion.</a:t>
+              <a:t>Client permissions, tenant isolation and explicit approval for legally or financially consequential actions come first. Autonomous official filing is not a current product claim.</a:t>
             </a:r>
             <a:endParaRPr lang="en-US" sz="1500" dirty="0"/>
           </a:p>
@@ -3727,7 +4186,7 @@
                 <a:ea typeface="Aptos" pitchFamily="34" charset="-122"/>
                 <a:cs typeface="Aptos" pitchFamily="34" charset="-120"/>
               </a:rPr>
-              <a:t>08 / 09</a:t>
+              <a:t>08 / 10</a:t>
             </a:r>
             <a:endParaRPr lang="en-US" sz="700" dirty="0"/>
           </a:p>
@@ -3898,7 +4357,7 @@
                 <a:ea typeface="Georgia" pitchFamily="34" charset="-122"/>
                 <a:cs typeface="Georgia" pitchFamily="34" charset="-120"/>
               </a:rPr>
-              <a:t>Let's discuss the evidence</a:t>
+              <a:t>What we are raising</a:t>
             </a:r>
             <a:endParaRPr lang="en-US" sz="3000" dirty="0"/>
           </a:p>
@@ -3939,7 +4398,7 @@
                 <a:ea typeface="Aptos" pitchFamily="34" charset="-122"/>
                 <a:cs typeface="Aptos" pitchFamily="34" charset="-120"/>
               </a:rPr>
-              <a:t>We can share a product demonstration using synthetic documents, a staged commercial-validation plan and a detailed investment case through controlled access.</a:t>
+              <a:t>We seek €1 million to complete commercial development, launch in Romania, strengthen delivery capacity and establish the first repeatable European expansion and distribution pathways.</a:t>
             </a:r>
             <a:endParaRPr lang="en-US" sz="1500" dirty="0"/>
           </a:p>
@@ -3956,16 +4415,38 @@
                 <a:ea typeface="Aptos" pitchFamily="34" charset="-122"/>
                 <a:cs typeface="Aptos" pitchFamily="34" charset="-120"/>
               </a:rPr>
-              <a:t>Cristian Apostol · Managing Partner</a:t>
+              <a:t>We are interested in lead and co-investors with B2B software, logistics, international trade or AI-workflow expertise. Investment structure and valuation are open for discussion.</a:t>
             </a:r>
             <a:endParaRPr lang="en-US" sz="1500" dirty="0"/>
           </a:p>
-          <a:p>
-            <a:pPr indent="0" marL="0">
-              <a:buNone/>
-            </a:pPr>
-            <a:r>
-              <a:rPr lang="en-US" sz="1500" dirty="0">
+        </p:txBody>
+      </p:sp>
+      <p:sp>
+        <p:nvSpPr>
+          <p:cNvPr id="7" name="Text 4"/>
+          <p:cNvSpPr/>
+          <p:nvPr/>
+        </p:nvSpPr>
+        <p:spPr>
+          <a:xfrm>
+            <a:off x="10789920" y="6473952"/>
+            <a:ext cx="822960" cy="146304"/>
+          </a:xfrm>
+          <a:prstGeom prst="rect">
+            <a:avLst/>
+          </a:prstGeom>
+          <a:noFill/>
+          <a:ln/>
+        </p:spPr>
+        <p:txBody>
+          <a:bodyPr wrap="square" lIns="0" tIns="0" rIns="0" bIns="0" rtlCol="0" anchor="ctr"/>
+          <a:lstStyle/>
+          <a:p>
+            <a:pPr algn="r" indent="0" marL="0">
+              <a:buNone/>
+            </a:pPr>
+            <a:r>
+              <a:rPr lang="en-US" sz="700" dirty="0">
                 <a:solidFill>
                   <a:srgbClr val="607277"/>
                 </a:solidFill>
@@ -3973,80 +4454,7 @@
                 <a:ea typeface="Aptos" pitchFamily="34" charset="-122"/>
                 <a:cs typeface="Aptos" pitchFamily="34" charset="-120"/>
               </a:rPr>
-              <a:t>CLARIFIED SRL · Bucharest, Romania</a:t>
-            </a:r>
-            <a:endParaRPr lang="en-US" sz="1500" dirty="0"/>
-          </a:p>
-          <a:p>
-            <a:pPr indent="0" marL="0">
-              <a:buNone/>
-            </a:pPr>
-            <a:r>
-              <a:rPr lang="en-US" sz="1500" dirty="0">
-                <a:solidFill>
-                  <a:srgbClr val="607277"/>
-                </a:solidFill>
-                <a:latin typeface="Aptos" pitchFamily="34" charset="0"/>
-                <a:ea typeface="Aptos" pitchFamily="34" charset="-122"/>
-                <a:cs typeface="Aptos" pitchFamily="34" charset="-120"/>
-              </a:rPr>
-              <a:t>office@clarified.ro · https://goodspass.ro</a:t>
-            </a:r>
-            <a:endParaRPr lang="en-US" sz="1500" dirty="0"/>
-          </a:p>
-          <a:p>
-            <a:pPr indent="0" marL="0">
-              <a:buNone/>
-            </a:pPr>
-            <a:r>
-              <a:rPr lang="en-US" sz="1500" dirty="0">
-                <a:solidFill>
-                  <a:srgbClr val="607277"/>
-                </a:solidFill>
-                <a:latin typeface="Aptos" pitchFamily="34" charset="0"/>
-                <a:ea typeface="Aptos" pitchFamily="34" charset="-122"/>
-                <a:cs typeface="Aptos" pitchFamily="34" charset="-120"/>
-              </a:rPr>
-              <a:t>This introduction is non-confidential. It is not a funding commitment, investment guarantee or claim of regulatory approval.</a:t>
-            </a:r>
-            <a:endParaRPr lang="en-US" sz="1500" dirty="0"/>
-          </a:p>
-        </p:txBody>
-      </p:sp>
-      <p:sp>
-        <p:nvSpPr>
-          <p:cNvPr id="7" name="Text 4"/>
-          <p:cNvSpPr/>
-          <p:nvPr/>
-        </p:nvSpPr>
-        <p:spPr>
-          <a:xfrm>
-            <a:off x="10789920" y="6473952"/>
-            <a:ext cx="822960" cy="146304"/>
-          </a:xfrm>
-          <a:prstGeom prst="rect">
-            <a:avLst/>
-          </a:prstGeom>
-          <a:noFill/>
-          <a:ln/>
-        </p:spPr>
-        <p:txBody>
-          <a:bodyPr wrap="square" lIns="0" tIns="0" rIns="0" bIns="0" rtlCol="0" anchor="ctr"/>
-          <a:lstStyle/>
-          <a:p>
-            <a:pPr algn="r" indent="0" marL="0">
-              <a:buNone/>
-            </a:pPr>
-            <a:r>
-              <a:rPr lang="en-US" sz="700" dirty="0">
-                <a:solidFill>
-                  <a:srgbClr val="607277"/>
-                </a:solidFill>
-                <a:latin typeface="Aptos" pitchFamily="34" charset="0"/>
-                <a:ea typeface="Aptos" pitchFamily="34" charset="-122"/>
-                <a:cs typeface="Aptos" pitchFamily="34" charset="-120"/>
-              </a:rPr>
-              <a:t>09 / 09</a:t>
+              <a:t>09 / 10</a:t>
             </a:r>
             <a:endParaRPr lang="en-US" sz="700" dirty="0"/>
           </a:p>

</xml_diff>